<commit_message>
Update 스피드 스태킹 assets and add ZIP slides
Co-Authored-By: Claude Opus 4.6 (1M context) <noreply@anthropic.com>
</commit_message>
<xml_diff>
--- a/public/downloads/games/cup-speed-stacking/rules.pptx
+++ b/public/downloads/games/cup-speed-stacking/rules.pptx
@@ -24,16 +24,12 @@
   <p:notesSz cx="6858000" cy="9144000"/>
   <p:embeddedFontLst>
     <p:embeddedFont>
-      <p:font typeface="Jua" charset="1" panose="00000000000000000000"/>
+      <p:font typeface="무궁화 고딕" charset="1" panose="02020603020101020101"/>
       <p:regular r:id="rId20"/>
     </p:embeddedFont>
     <p:embeddedFont>
-      <p:font typeface="TDTD갬성명조" charset="1" panose="02000503000000000000"/>
+      <p:font typeface="무궁화 고딕 Bold" charset="1" panose="02020603020101020101"/>
       <p:regular r:id="rId21"/>
-    </p:embeddedFont>
-    <p:embeddedFont>
-      <p:font typeface="TDTD가온" charset="1" panose="02000503000000000000"/>
-      <p:regular r:id="rId22"/>
     </p:embeddedFont>
   </p:embeddedFontLst>
   <p:defaultTextStyle>
@@ -3151,8 +3147,8 @@
         </p:nvSpPr>
         <p:spPr>
           <a:xfrm rot="0">
-            <a:off x="1028700" y="3892867"/>
-            <a:ext cx="15555091" cy="2200275"/>
+            <a:off x="1028700" y="4178617"/>
+            <a:ext cx="15555091" cy="1914525"/>
           </a:xfrm>
           <a:prstGeom prst="rect">
             <a:avLst/>
@@ -3174,10 +3170,10 @@
                 <a:solidFill>
                   <a:srgbClr val="FFFAEF"/>
                 </a:solidFill>
-                <a:latin typeface="Jua"/>
-                <a:ea typeface="Jua"/>
-                <a:cs typeface="Jua"/>
-                <a:sym typeface="Jua"/>
+                <a:latin typeface="무궁화 고딕"/>
+                <a:ea typeface="무궁화 고딕"/>
+                <a:cs typeface="무궁화 고딕"/>
+                <a:sym typeface="무궁화 고딕"/>
               </a:rPr>
               <a:t>스피드 스태킹</a:t>
             </a:r>
@@ -3192,8 +3188,8 @@
         </p:nvSpPr>
         <p:spPr>
           <a:xfrm rot="0">
-            <a:off x="15264803" y="9812655"/>
-            <a:ext cx="2637975" cy="474345"/>
+            <a:off x="14442645" y="9822180"/>
+            <a:ext cx="3460133" cy="464820"/>
           </a:xfrm>
           <a:prstGeom prst="rect">
             <a:avLst/>
@@ -3218,10 +3214,10 @@
                 <a:solidFill>
                   <a:srgbClr val="FFFFFF"/>
                 </a:solidFill>
-                <a:latin typeface="TDTD갬성명조"/>
-                <a:ea typeface="TDTD갬성명조"/>
-                <a:cs typeface="TDTD갬성명조"/>
-                <a:sym typeface="TDTD갬성명조"/>
+                <a:latin typeface="무궁화 고딕"/>
+                <a:ea typeface="무궁화 고딕"/>
+                <a:cs typeface="무궁화 고딕"/>
+                <a:sym typeface="무궁화 고딕"/>
               </a:rPr>
               <a:t>ⓒ 2026. Sunday Play</a:t>
             </a:r>
@@ -5693,8 +5689,8 @@
         </p:nvSpPr>
         <p:spPr>
           <a:xfrm rot="0">
-            <a:off x="4421807" y="3895725"/>
-            <a:ext cx="9444385" cy="2200275"/>
+            <a:off x="4421807" y="4181475"/>
+            <a:ext cx="9444385" cy="1914525"/>
           </a:xfrm>
           <a:prstGeom prst="rect">
             <a:avLst/>
@@ -5716,10 +5712,10 @@
                 <a:solidFill>
                   <a:srgbClr val="000000"/>
                 </a:solidFill>
-                <a:latin typeface="Jua"/>
-                <a:ea typeface="Jua"/>
-                <a:cs typeface="Jua"/>
-                <a:sym typeface="Jua"/>
+                <a:latin typeface="무궁화 고딕"/>
+                <a:ea typeface="무궁화 고딕"/>
+                <a:cs typeface="무궁화 고딕"/>
+                <a:sym typeface="무궁화 고딕"/>
               </a:rPr>
               <a:t>감사합니다!</a:t>
             </a:r>
@@ -5918,8 +5914,8 @@
         </p:nvSpPr>
         <p:spPr>
           <a:xfrm rot="0">
-            <a:off x="11392761" y="600705"/>
-            <a:ext cx="5362043" cy="1600200"/>
+            <a:off x="11392761" y="819780"/>
+            <a:ext cx="5362043" cy="1381125"/>
           </a:xfrm>
           <a:prstGeom prst="rect">
             <a:avLst/>
@@ -5941,10 +5937,10 @@
                 <a:solidFill>
                   <a:srgbClr val="FFFAEF"/>
                 </a:solidFill>
-                <a:latin typeface="Jua"/>
-                <a:ea typeface="Jua"/>
-                <a:cs typeface="Jua"/>
-                <a:sym typeface="Jua"/>
+                <a:latin typeface="무궁화 고딕"/>
+                <a:ea typeface="무궁화 고딕"/>
+                <a:cs typeface="무궁화 고딕"/>
+                <a:sym typeface="무궁화 고딕"/>
               </a:rPr>
               <a:t>규칙</a:t>
             </a:r>
@@ -5960,9 +5956,9 @@
         <p:grpSpPr>
           <a:xfrm rot="0">
             <a:off x="309172" y="535073"/>
-            <a:ext cx="10694683" cy="2573620"/>
+            <a:ext cx="10694683" cy="2406534"/>
             <a:chOff x="0" y="0"/>
-            <a:chExt cx="14259577" cy="3431493"/>
+            <a:chExt cx="14259577" cy="3208711"/>
           </a:xfrm>
         </p:grpSpPr>
         <p:sp>
@@ -5973,8 +5969,8 @@
           </p:nvSpPr>
           <p:spPr>
             <a:xfrm rot="0">
-              <a:off x="0" y="1380584"/>
-              <a:ext cx="14259577" cy="2050910"/>
+              <a:off x="0" y="1388378"/>
+              <a:ext cx="14259577" cy="1820333"/>
             </a:xfrm>
             <a:prstGeom prst="rect">
               <a:avLst/>
@@ -5988,18 +5984,18 @@
             <a:p>
               <a:pPr algn="l">
                 <a:lnSpc>
-                  <a:spcPts val="6273"/>
+                  <a:spcPts val="5599"/>
                 </a:lnSpc>
               </a:pPr>
               <a:r>
-                <a:rPr lang="en-US" sz="4480">
+                <a:rPr lang="en-US" sz="3999">
                   <a:solidFill>
                     <a:srgbClr val="FFFAEF"/>
                   </a:solidFill>
-                  <a:latin typeface="TDTD가온"/>
-                  <a:ea typeface="TDTD가온"/>
-                  <a:cs typeface="TDTD가온"/>
-                  <a:sym typeface="TDTD가온"/>
+                  <a:latin typeface="무궁화 고딕"/>
+                  <a:ea typeface="무궁화 고딕"/>
+                  <a:cs typeface="무궁화 고딕"/>
+                  <a:sym typeface="무궁화 고딕"/>
                 </a:rPr>
                 <a:t>팀을 나누고 출발선 뒤에 한 줄로 섭니다.                                     </a:t>
               </a:r>
@@ -6007,20 +6003,20 @@
             <a:p>
               <a:pPr algn="l">
                 <a:lnSpc>
-                  <a:spcPts val="6273"/>
+                  <a:spcPts val="5599"/>
                 </a:lnSpc>
               </a:pPr>
               <a:r>
-                <a:rPr lang="en-US" sz="4480">
+                <a:rPr lang="en-US" sz="3999">
                   <a:solidFill>
                     <a:srgbClr val="FFFAEF"/>
                   </a:solidFill>
-                  <a:latin typeface="TDTD가온"/>
-                  <a:ea typeface="TDTD가온"/>
-                  <a:cs typeface="TDTD가온"/>
-                  <a:sym typeface="TDTD가온"/>
+                  <a:latin typeface="무궁화 고딕"/>
+                  <a:ea typeface="무궁화 고딕"/>
+                  <a:cs typeface="무궁화 고딕"/>
+                  <a:sym typeface="무궁화 고딕"/>
                 </a:rPr>
-                <a:t> 컵은 책상 위에 정리해 둡니다.</a:t>
+                <a:t>컵은 책상 위에 정리해 둡니다.</a:t>
               </a:r>
             </a:p>
           </p:txBody>
@@ -6033,8 +6029,8 @@
           </p:nvSpPr>
           <p:spPr>
             <a:xfrm rot="0">
-              <a:off x="0" y="-171450"/>
-              <a:ext cx="9574913" cy="1169217"/>
+              <a:off x="0" y="-66675"/>
+              <a:ext cx="9574913" cy="1062712"/>
             </a:xfrm>
             <a:prstGeom prst="rect">
               <a:avLst/>
@@ -6056,10 +6052,10 @@
                   <a:solidFill>
                     <a:srgbClr val="FFFAEF"/>
                   </a:solidFill>
-                  <a:latin typeface="Jua"/>
-                  <a:ea typeface="Jua"/>
-                  <a:cs typeface="Jua"/>
-                  <a:sym typeface="Jua"/>
+                  <a:latin typeface="무궁화 고딕 Bold"/>
+                  <a:ea typeface="무궁화 고딕 Bold"/>
+                  <a:cs typeface="무궁화 고딕 Bold"/>
+                  <a:sym typeface="무궁화 고딕 Bold"/>
                 </a:rPr>
                 <a:t>STEP 1.</a:t>
               </a:r>
@@ -6076,9 +6072,9 @@
         <p:grpSpPr>
           <a:xfrm rot="0">
             <a:off x="9449221" y="8200435"/>
-            <a:ext cx="8687650" cy="1778769"/>
+            <a:ext cx="8687650" cy="1697862"/>
             <a:chOff x="0" y="0"/>
-            <a:chExt cx="11583533" cy="2371692"/>
+            <a:chExt cx="11583533" cy="2263816"/>
           </a:xfrm>
         </p:grpSpPr>
         <p:sp>
@@ -6089,8 +6085,8 @@
           </p:nvSpPr>
           <p:spPr>
             <a:xfrm rot="0">
-              <a:off x="0" y="1377534"/>
-              <a:ext cx="11406442" cy="994158"/>
+              <a:off x="0" y="1373758"/>
+              <a:ext cx="11406442" cy="890058"/>
             </a:xfrm>
             <a:prstGeom prst="rect">
               <a:avLst/>
@@ -6104,18 +6100,18 @@
             <a:p>
               <a:pPr algn="l">
                 <a:lnSpc>
-                  <a:spcPts val="6284"/>
+                  <a:spcPts val="5600"/>
                 </a:lnSpc>
               </a:pPr>
               <a:r>
-                <a:rPr lang="en-US" sz="4489">
+                <a:rPr lang="en-US" sz="4000">
                   <a:solidFill>
                     <a:srgbClr val="FFFAEF"/>
                   </a:solidFill>
-                  <a:latin typeface="TDTD가온"/>
-                  <a:ea typeface="TDTD가온"/>
-                  <a:cs typeface="TDTD가온"/>
-                  <a:sym typeface="TDTD가온"/>
+                  <a:latin typeface="무궁화 고딕"/>
+                  <a:ea typeface="무궁화 고딕"/>
+                  <a:cs typeface="무궁화 고딕"/>
+                  <a:sym typeface="무궁화 고딕"/>
                 </a:rPr>
                 <a:t>패턴을 가장 먼저 정확히 완성한 팀이 승리!</a:t>
               </a:r>
@@ -6130,8 +6126,8 @@
           </p:nvSpPr>
           <p:spPr>
             <a:xfrm rot="0">
-              <a:off x="0" y="-171450"/>
-              <a:ext cx="11583533" cy="1171105"/>
+              <a:off x="0" y="-57150"/>
+              <a:ext cx="11583533" cy="1053029"/>
             </a:xfrm>
             <a:prstGeom prst="rect">
               <a:avLst/>
@@ -6153,10 +6149,10 @@
                   <a:solidFill>
                     <a:srgbClr val="FFFAEF"/>
                   </a:solidFill>
-                  <a:latin typeface="Jua"/>
-                  <a:ea typeface="Jua"/>
-                  <a:cs typeface="Jua"/>
-                  <a:sym typeface="Jua"/>
+                  <a:latin typeface="무궁화 고딕 Bold"/>
+                  <a:ea typeface="무궁화 고딕 Bold"/>
+                  <a:cs typeface="무궁화 고딕 Bold"/>
+                  <a:sym typeface="무궁화 고딕 Bold"/>
                 </a:rPr>
                 <a:t>STEP 3.</a:t>
               </a:r>
@@ -6173,9 +6169,9 @@
         <p:grpSpPr>
           <a:xfrm rot="0">
             <a:off x="4621704" y="3858476"/>
-            <a:ext cx="9074156" cy="3364141"/>
+            <a:ext cx="9074156" cy="3107111"/>
             <a:chOff x="0" y="0"/>
-            <a:chExt cx="12098875" cy="4485521"/>
+            <a:chExt cx="12098875" cy="4142815"/>
           </a:xfrm>
         </p:grpSpPr>
         <p:sp>
@@ -6186,8 +6182,8 @@
           </p:nvSpPr>
           <p:spPr>
             <a:xfrm rot="0">
-              <a:off x="0" y="1375218"/>
-              <a:ext cx="12098875" cy="3110303"/>
+              <a:off x="0" y="1382681"/>
+              <a:ext cx="12098875" cy="2760133"/>
             </a:xfrm>
             <a:prstGeom prst="rect">
               <a:avLst/>
@@ -6201,18 +6197,18 @@
             <a:p>
               <a:pPr algn="l">
                 <a:lnSpc>
-                  <a:spcPts val="6275"/>
+                  <a:spcPts val="5599"/>
                 </a:lnSpc>
               </a:pPr>
               <a:r>
-                <a:rPr lang="en-US" sz="4482">
+                <a:rPr lang="en-US" sz="3999">
                   <a:solidFill>
                     <a:srgbClr val="FFFAEF"/>
                   </a:solidFill>
-                  <a:latin typeface="TDTD가온"/>
-                  <a:ea typeface="TDTD가온"/>
-                  <a:cs typeface="TDTD가온"/>
-                  <a:sym typeface="TDTD가온"/>
+                  <a:latin typeface="무궁화 고딕"/>
+                  <a:ea typeface="무궁화 고딕"/>
+                  <a:cs typeface="무궁화 고딕"/>
+                  <a:sym typeface="무궁화 고딕"/>
                 </a:rPr>
                 <a:t>화면에 패턴이 나오면 한 명씩 달려가 컵 1개를 놓고 돌아옵니다.                         </a:t>
               </a:r>
@@ -6220,18 +6216,18 @@
             <a:p>
               <a:pPr algn="l">
                 <a:lnSpc>
-                  <a:spcPts val="6275"/>
+                  <a:spcPts val="5599"/>
                 </a:lnSpc>
               </a:pPr>
               <a:r>
-                <a:rPr lang="en-US" sz="4482">
+                <a:rPr lang="en-US" sz="3999">
                   <a:solidFill>
                     <a:srgbClr val="FFFAEF"/>
                   </a:solidFill>
-                  <a:latin typeface="TDTD가온"/>
-                  <a:ea typeface="TDTD가온"/>
-                  <a:cs typeface="TDTD가온"/>
-                  <a:sym typeface="TDTD가온"/>
+                  <a:latin typeface="무궁화 고딕"/>
+                  <a:ea typeface="무궁화 고딕"/>
+                  <a:cs typeface="무궁화 고딕"/>
+                  <a:sym typeface="무궁화 고딕"/>
                 </a:rPr>
                 <a:t>바톤터치 후 다음 사람이 출발합니다.</a:t>
               </a:r>
@@ -6246,8 +6242,8 @@
           </p:nvSpPr>
           <p:spPr>
             <a:xfrm rot="0">
-              <a:off x="0" y="-171450"/>
-              <a:ext cx="7079955" cy="1169523"/>
+              <a:off x="0" y="-57150"/>
+              <a:ext cx="7079955" cy="1053161"/>
             </a:xfrm>
             <a:prstGeom prst="rect">
               <a:avLst/>
@@ -6269,10 +6265,10 @@
                   <a:solidFill>
                     <a:srgbClr val="FFFAEF"/>
                   </a:solidFill>
-                  <a:latin typeface="Jua"/>
-                  <a:ea typeface="Jua"/>
-                  <a:cs typeface="Jua"/>
-                  <a:sym typeface="Jua"/>
+                  <a:latin typeface="무궁화 고딕 Bold"/>
+                  <a:ea typeface="무궁화 고딕 Bold"/>
+                  <a:cs typeface="무궁화 고딕 Bold"/>
+                  <a:sym typeface="무궁화 고딕 Bold"/>
                 </a:rPr>
                 <a:t>STEP 2.</a:t>
               </a:r>
@@ -6320,8 +6316,8 @@
         </p:nvSpPr>
         <p:spPr>
           <a:xfrm rot="0">
-            <a:off x="3238925" y="4092795"/>
-            <a:ext cx="11810151" cy="2200275"/>
+            <a:off x="3238925" y="4378545"/>
+            <a:ext cx="11810151" cy="1914525"/>
           </a:xfrm>
           <a:prstGeom prst="rect">
             <a:avLst/>
@@ -6343,10 +6339,10 @@
                 <a:solidFill>
                   <a:srgbClr val="000000"/>
                 </a:solidFill>
-                <a:latin typeface="Jua"/>
-                <a:ea typeface="Jua"/>
-                <a:cs typeface="Jua"/>
-                <a:sym typeface="Jua"/>
+                <a:latin typeface="무궁화 고딕"/>
+                <a:ea typeface="무궁화 고딕"/>
+                <a:cs typeface="무궁화 고딕"/>
+                <a:sym typeface="무궁화 고딕"/>
               </a:rPr>
               <a:t>팀을 나눠주세요!</a:t>
             </a:r>
@@ -6493,8 +6489,8 @@
         </p:nvSpPr>
         <p:spPr>
           <a:xfrm rot="0">
-            <a:off x="1028700" y="3892867"/>
-            <a:ext cx="15555091" cy="2200275"/>
+            <a:off x="1028700" y="4178617"/>
+            <a:ext cx="15555091" cy="1914525"/>
           </a:xfrm>
           <a:prstGeom prst="rect">
             <a:avLst/>
@@ -6516,10 +6512,10 @@
                 <a:solidFill>
                   <a:srgbClr val="FFFAEF"/>
                 </a:solidFill>
-                <a:latin typeface="Jua"/>
-                <a:ea typeface="Jua"/>
-                <a:cs typeface="Jua"/>
-                <a:sym typeface="Jua"/>
+                <a:latin typeface="무궁화 고딕"/>
+                <a:ea typeface="무궁화 고딕"/>
+                <a:cs typeface="무궁화 고딕"/>
+                <a:sym typeface="무궁화 고딕"/>
               </a:rPr>
               <a:t>스피드 스태킹</a:t>
             </a:r>
@@ -6534,8 +6530,8 @@
         </p:nvSpPr>
         <p:spPr>
           <a:xfrm rot="0">
-            <a:off x="15264803" y="9812655"/>
-            <a:ext cx="2637975" cy="474345"/>
+            <a:off x="14442645" y="9822180"/>
+            <a:ext cx="3460133" cy="464820"/>
           </a:xfrm>
           <a:prstGeom prst="rect">
             <a:avLst/>
@@ -6560,10 +6556,10 @@
                 <a:solidFill>
                   <a:srgbClr val="FFFFFF"/>
                 </a:solidFill>
-                <a:latin typeface="TDTD갬성명조"/>
-                <a:ea typeface="TDTD갬성명조"/>
-                <a:cs typeface="TDTD갬성명조"/>
-                <a:sym typeface="TDTD갬성명조"/>
+                <a:latin typeface="무궁화 고딕"/>
+                <a:ea typeface="무궁화 고딕"/>
+                <a:cs typeface="무궁화 고딕"/>
+                <a:sym typeface="무궁화 고딕"/>
               </a:rPr>
               <a:t>ⓒ 2026. Sunday Play</a:t>
             </a:r>

</xml_diff>